<commit_message>
Update workshop slides and content for Teknocamp 2026
</commit_message>
<xml_diff>
--- a/slides/pptx/tc26-modul03_del01.pptx
+++ b/slides/pptx/tc26-modul03_del01.pptx
@@ -4,9 +4,6 @@
   <p:sldMasterIdLst>
     <p:sldMasterId id="2147483648" r:id="rId1"/>
   </p:sldMasterIdLst>
-  <p:notesMasterIdLst>
-    <p:notesMasterId r:id="rId8"/>
-  </p:notesMasterIdLst>
   <p:sldIdLst>
     <p:sldId id="256" r:id="rId2"/>
     <p:sldId id="257" r:id="rId3"/>
@@ -14,7 +11,11 @@
     <p:sldId id="259" r:id="rId5"/>
     <p:sldId id="260" r:id="rId6"/>
     <p:sldId id="261" r:id="rId7"/>
+    <p:sldId id="262" r:id="rId8"/>
   </p:sldIdLst>
+  <p:notesMasterIdLst>
+    <p:notesMasterId r:id="rId9"/>
+  </p:notesMasterIdLst>
   <p:sldSz cx="12192000" cy="6858000"/>
   <p:notesSz cx="6858000" cy="12192000"/>
   <p:defaultTextStyle>
@@ -109,11 +110,6 @@
       </a:defRPr>
     </a:lvl9pPr>
   </p:defaultTextStyle>
-  <p:extLst>
-    <p:ext uri="{EFAFB233-063F-42B5-8137-9DF3F51BA10A}">
-      <p15:sldGuideLst xmlns:p15="http://schemas.microsoft.com/office/powerpoint/2012/main"/>
-    </p:ext>
-  </p:extLst>
 </p:presentation>
 </file>
 
@@ -139,10 +135,234 @@
           <a:chExt cx="0" cy="0"/>
         </a:xfrm>
       </p:grpSpPr>
+      <p:sp>
+        <p:nvSpPr>
+          <p:cNvPr id="2" name="Header Placeholder 1"/>
+          <p:cNvSpPr>
+            <a:spLocks noGrp="1"/>
+          </p:cNvSpPr>
+          <p:nvPr>
+            <p:ph type="hdr" sz="quarter"/>
+          </p:nvPr>
+        </p:nvSpPr>
+        <p:spPr>
+          <a:xfrm>
+            <a:off x="0" y="0"/>
+            <a:ext cx="2971800" cy="458788"/>
+          </a:xfrm>
+          <a:prstGeom prst="rect">
+            <a:avLst/>
+          </a:prstGeom>
+        </p:spPr>
+        <p:txBody>
+          <a:bodyPr vert="horz" lIns="91440" tIns="45720" rIns="91440" bIns="45720" rtlCol="0"/>
+          <a:lstStyle>
+            <a:lvl1pPr algn="l">
+              <a:defRPr sz="1200"/>
+            </a:lvl1pPr>
+          </a:lstStyle>
+          <a:p>
+            <a:endParaRPr lang="en-US"/>
+          </a:p>
+        </p:txBody>
+      </p:sp>
+      <p:sp>
+        <p:nvSpPr>
+          <p:cNvPr id="3" name="Date Placeholder 2"/>
+          <p:cNvSpPr>
+            <a:spLocks noGrp="1"/>
+          </p:cNvSpPr>
+          <p:nvPr>
+            <p:ph type="dt" idx="1"/>
+          </p:nvPr>
+        </p:nvSpPr>
+        <p:spPr>
+          <a:xfrm>
+            <a:off x="3884613" y="0"/>
+            <a:ext cx="2971800" cy="458788"/>
+          </a:xfrm>
+          <a:prstGeom prst="rect">
+            <a:avLst/>
+          </a:prstGeom>
+        </p:spPr>
+        <p:txBody>
+          <a:bodyPr vert="horz" lIns="91440" tIns="45720" rIns="91440" bIns="45720" rtlCol="0"/>
+          <a:lstStyle>
+            <a:lvl1pPr algn="r">
+              <a:defRPr sz="1200"/>
+            </a:lvl1pPr>
+          </a:lstStyle>
+          <a:p>
+            <a:fld id="{5282F153-3F37-0F45-9E97-73ACFA13230C}" type="datetimeFigureOut">
+              <a:rPr lang="en-US"/>
+              <a:t>7/23/19</a:t>
+            </a:fld>
+            <a:endParaRPr lang="en-US"/>
+          </a:p>
+        </p:txBody>
+      </p:sp>
+      <p:sp>
+        <p:nvSpPr>
+          <p:cNvPr id="4" name="Slide Image Placeholder 3"/>
+          <p:cNvSpPr>
+            <a:spLocks noGrp="1" noRot="1" noChangeAspect="1"/>
+          </p:cNvSpPr>
+          <p:nvPr>
+            <p:ph type="sldImg" idx="2"/>
+          </p:nvPr>
+        </p:nvSpPr>
+        <p:spPr>
+          <a:xfrm>
+            <a:off x="685800" y="1143000"/>
+            <a:ext cx="5486400" cy="3086100"/>
+          </a:xfrm>
+          <a:prstGeom prst="rect">
+            <a:avLst/>
+          </a:prstGeom>
+          <a:noFill/>
+          <a:ln w="12700">
+            <a:solidFill>
+              <a:prstClr val="black"/>
+            </a:solidFill>
+          </a:ln>
+        </p:spPr>
+        <p:txBody>
+          <a:bodyPr vert="horz" lIns="91440" tIns="45720" rIns="91440" bIns="45720" rtlCol="0" anchor="ctr"/>
+          <a:lstStyle/>
+          <a:p>
+            <a:endParaRPr lang="en-US"/>
+          </a:p>
+        </p:txBody>
+      </p:sp>
+      <p:sp>
+        <p:nvSpPr>
+          <p:cNvPr id="5" name="Notes Placeholder 4"/>
+          <p:cNvSpPr>
+            <a:spLocks noGrp="1"/>
+          </p:cNvSpPr>
+          <p:nvPr>
+            <p:ph type="body" sz="quarter" idx="3"/>
+          </p:nvPr>
+        </p:nvSpPr>
+        <p:spPr>
+          <a:xfrm>
+            <a:off x="685800" y="4400550"/>
+            <a:ext cx="5486400" cy="3600450"/>
+          </a:xfrm>
+          <a:prstGeom prst="rect">
+            <a:avLst/>
+          </a:prstGeom>
+        </p:spPr>
+        <p:txBody>
+          <a:bodyPr vert="horz" lIns="91440" tIns="45720" rIns="91440" bIns="45720" rtlCol="0"/>
+          <a:lstStyle/>
+          <a:p>
+            <a:pPr lvl="0"/>
+            <a:r>
+              <a:rPr lang="en-US"/>
+              <a:t>Click to edit Master text styles</a:t>
+            </a:r>
+          </a:p>
+          <a:p>
+            <a:pPr lvl="1"/>
+            <a:r>
+              <a:rPr lang="en-US"/>
+              <a:t>Second level</a:t>
+            </a:r>
+          </a:p>
+          <a:p>
+            <a:pPr lvl="2"/>
+            <a:r>
+              <a:rPr lang="en-US"/>
+              <a:t>Third level</a:t>
+            </a:r>
+          </a:p>
+          <a:p>
+            <a:pPr lvl="3"/>
+            <a:r>
+              <a:rPr lang="en-US"/>
+              <a:t>Fourth level</a:t>
+            </a:r>
+          </a:p>
+          <a:p>
+            <a:pPr lvl="4"/>
+            <a:r>
+              <a:rPr lang="en-US"/>
+              <a:t>Fifth level</a:t>
+            </a:r>
+          </a:p>
+        </p:txBody>
+      </p:sp>
+      <p:sp>
+        <p:nvSpPr>
+          <p:cNvPr id="6" name="Footer Placeholder 5"/>
+          <p:cNvSpPr>
+            <a:spLocks noGrp="1"/>
+          </p:cNvSpPr>
+          <p:nvPr>
+            <p:ph type="ftr" sz="quarter" idx="4"/>
+          </p:nvPr>
+        </p:nvSpPr>
+        <p:spPr>
+          <a:xfrm>
+            <a:off x="0" y="8685213"/>
+            <a:ext cx="2971800" cy="458787"/>
+          </a:xfrm>
+          <a:prstGeom prst="rect">
+            <a:avLst/>
+          </a:prstGeom>
+        </p:spPr>
+        <p:txBody>
+          <a:bodyPr vert="horz" lIns="91440" tIns="45720" rIns="91440" bIns="45720" rtlCol="0" anchor="b"/>
+          <a:lstStyle>
+            <a:lvl1pPr algn="l">
+              <a:defRPr sz="1200"/>
+            </a:lvl1pPr>
+          </a:lstStyle>
+          <a:p>
+            <a:endParaRPr lang="en-US"/>
+          </a:p>
+        </p:txBody>
+      </p:sp>
+      <p:sp>
+        <p:nvSpPr>
+          <p:cNvPr id="7" name="Slide Number Placeholder 6"/>
+          <p:cNvSpPr>
+            <a:spLocks noGrp="1"/>
+          </p:cNvSpPr>
+          <p:nvPr>
+            <p:ph type="sldNum" sz="quarter" idx="5"/>
+          </p:nvPr>
+        </p:nvSpPr>
+        <p:spPr>
+          <a:xfrm>
+            <a:off x="3884613" y="8685213"/>
+            <a:ext cx="2971800" cy="458787"/>
+          </a:xfrm>
+          <a:prstGeom prst="rect">
+            <a:avLst/>
+          </a:prstGeom>
+        </p:spPr>
+        <p:txBody>
+          <a:bodyPr vert="horz" lIns="91440" tIns="45720" rIns="91440" bIns="45720" rtlCol="0" anchor="b"/>
+          <a:lstStyle>
+            <a:lvl1pPr algn="r">
+              <a:defRPr sz="1200"/>
+            </a:lvl1pPr>
+          </a:lstStyle>
+          <a:p>
+            <a:fld id="{CE5E9CC1-C706-0F49-92D6-E571CC5EEA8F}" type="slidenum">
+              <a:rPr lang="en-US"/>
+              <a:t>‹#›</a:t>
+            </a:fld>
+            <a:endParaRPr lang="en-US"/>
+          </a:p>
+        </p:txBody>
+      </p:sp>
     </p:spTree>
     <p:extLst>
       <p:ext uri="{BB962C8B-B14F-4D97-AF65-F5344CB8AC3E}">
-        <p14:creationId xmlns:p14="http://schemas.microsoft.com/office/powerpoint/2010/main" val="961986516"/>
+        <p14:creationId xmlns:p14="http://schemas.microsoft.com/office/powerpoint/2010/main" val="1024086991"/>
       </p:ext>
     </p:extLst>
   </p:cSld>
@@ -286,6 +506,10 @@
           <a:bodyPr/>
           <a:lstStyle/>
           <a:p>
+            <a:r>
+              <a:rPr lang="en-US" dirty="0"/>
+              <a:t/>
+            </a:r>
             <a:endParaRPr lang="en-US" dirty="0"/>
           </a:p>
         </p:txBody>
@@ -370,6 +594,10 @@
           <a:bodyPr/>
           <a:lstStyle/>
           <a:p>
+            <a:r>
+              <a:rPr lang="en-US" dirty="0"/>
+              <a:t/>
+            </a:r>
             <a:endParaRPr lang="en-US" dirty="0"/>
           </a:p>
         </p:txBody>
@@ -454,6 +682,10 @@
           <a:bodyPr/>
           <a:lstStyle/>
           <a:p>
+            <a:r>
+              <a:rPr lang="en-US" dirty="0"/>
+              <a:t/>
+            </a:r>
             <a:endParaRPr lang="en-US" dirty="0"/>
           </a:p>
         </p:txBody>
@@ -538,6 +770,10 @@
           <a:bodyPr/>
           <a:lstStyle/>
           <a:p>
+            <a:r>
+              <a:rPr lang="en-US" dirty="0"/>
+              <a:t/>
+            </a:r>
             <a:endParaRPr lang="en-US" dirty="0"/>
           </a:p>
         </p:txBody>
@@ -622,6 +858,10 @@
           <a:bodyPr/>
           <a:lstStyle/>
           <a:p>
+            <a:r>
+              <a:rPr lang="en-US" dirty="0"/>
+              <a:t/>
+            </a:r>
             <a:endParaRPr lang="en-US" dirty="0"/>
           </a:p>
         </p:txBody>
@@ -706,6 +946,10 @@
           <a:bodyPr/>
           <a:lstStyle/>
           <a:p>
+            <a:r>
+              <a:rPr lang="en-US" dirty="0"/>
+              <a:t/>
+            </a:r>
             <a:endParaRPr lang="en-US" dirty="0"/>
           </a:p>
         </p:txBody>
@@ -728,6 +972,94 @@
             <a:fld id="{F7021451-1387-4CA6-816F-3879F97B5CBC}" type="slidenum">
               <a:rPr lang="en-US"/>
               <a:t>6</a:t>
+            </a:fld>
+            <a:endParaRPr lang="en-US"/>
+          </a:p>
+        </p:txBody>
+      </p:sp>
+    </p:spTree>
+    <p:extLst>
+      <p:ext uri="{BB962C8B-B14F-4D97-AF65-F5344CB8AC3E}">
+        <p14:creationId xmlns:p14="http://schemas.microsoft.com/office/powerpoint/2010/main" val="1024086991"/>
+      </p:ext>
+    </p:extLst>
+  </p:cSld>
+  <p:clrMapOvr>
+    <a:masterClrMapping/>
+  </p:clrMapOvr>
+</p:notes>
+</file>
+
+<file path=ppt/notesSlides/notesSlide7.xml><?xml version="1.0" encoding="utf-8"?>
+<p:notes xmlns:a="http://schemas.openxmlformats.org/drawingml/2006/main" xmlns:r="http://schemas.openxmlformats.org/officeDocument/2006/relationships" xmlns:p="http://schemas.openxmlformats.org/presentationml/2006/main">
+  <p:cSld>
+    <p:spTree>
+      <p:nvGrpSpPr>
+        <p:cNvPr id="1" name=""/>
+        <p:cNvGrpSpPr/>
+        <p:nvPr/>
+      </p:nvGrpSpPr>
+      <p:grpSpPr>
+        <a:xfrm>
+          <a:off x="0" y="0"/>
+          <a:ext cx="0" cy="0"/>
+          <a:chOff x="0" y="0"/>
+          <a:chExt cx="0" cy="0"/>
+        </a:xfrm>
+      </p:grpSpPr>
+      <p:sp>
+        <p:nvSpPr>
+          <p:cNvPr id="2" name="Slide Image Placeholder 1"/>
+          <p:cNvSpPr>
+            <a:spLocks noGrp="1" noRot="1" noChangeAspect="1"/>
+          </p:cNvSpPr>
+          <p:nvPr>
+            <p:ph type="sldImg"/>
+          </p:nvPr>
+        </p:nvSpPr>
+        <p:spPr/>
+      </p:sp>
+      <p:sp>
+        <p:nvSpPr>
+          <p:cNvPr id="3" name="Notes Placeholder 2"/>
+          <p:cNvSpPr>
+            <a:spLocks noGrp="1"/>
+          </p:cNvSpPr>
+          <p:nvPr>
+            <p:ph type="body" idx="1"/>
+          </p:nvPr>
+        </p:nvSpPr>
+        <p:spPr/>
+        <p:txBody>
+          <a:bodyPr/>
+          <a:lstStyle/>
+          <a:p>
+            <a:r>
+              <a:rPr lang="en-US" dirty="0"/>
+              <a:t/>
+            </a:r>
+            <a:endParaRPr lang="en-US" dirty="0"/>
+          </a:p>
+        </p:txBody>
+      </p:sp>
+      <p:sp>
+        <p:nvSpPr>
+          <p:cNvPr id="4" name="Slide Number Placeholder 3"/>
+          <p:cNvSpPr>
+            <a:spLocks noGrp="1"/>
+          </p:cNvSpPr>
+          <p:nvPr>
+            <p:ph type="sldNum" sz="quarter" idx="10"/>
+          </p:nvPr>
+        </p:nvSpPr>
+        <p:spPr/>
+        <p:txBody>
+          <a:bodyPr/>
+          <a:lstStyle/>
+          <a:p>
+            <a:fld id="{F7021451-1387-4CA6-816F-3879F97B5CBC}" type="slidenum">
+              <a:rPr lang="en-US"/>
+              <a:t>7</a:t>
             </a:fld>
             <a:endParaRPr lang="en-US"/>
           </a:p>
@@ -779,11 +1111,6 @@
 <file path=ppt/slideMasters/slideMaster1.xml><?xml version="1.0" encoding="utf-8"?>
 <p:sldMaster xmlns:a="http://schemas.openxmlformats.org/drawingml/2006/main" xmlns:r="http://schemas.openxmlformats.org/officeDocument/2006/relationships" xmlns:p="http://schemas.openxmlformats.org/presentationml/2006/main">
   <p:cSld>
-    <p:bg>
-      <p:bgRef idx="1001">
-        <a:schemeClr val="bg1"/>
-      </p:bgRef>
-    </p:bg>
     <p:spTree>
       <p:nvGrpSpPr>
         <p:cNvPr id="1" name=""/>
@@ -798,55 +1125,6 @@
           <a:chExt cx="0" cy="0"/>
         </a:xfrm>
       </p:grpSpPr>
-      <p:sp>
-        <p:nvSpPr>
-          <p:cNvPr id="3" name="TextBox 2">
-            <a:extLst>
-              <a:ext uri="{FF2B5EF4-FFF2-40B4-BE49-F238E27FC236}">
-                <a16:creationId xmlns:a16="http://schemas.microsoft.com/office/drawing/2014/main" id="{8A391835-D231-357B-2C91-BFCE35FAEB08}"/>
-              </a:ext>
-            </a:extLst>
-          </p:cNvPr>
-          <p:cNvSpPr txBox="1"/>
-          <p:nvPr userDrawn="1">
-            <p:extLst>
-              <p:ext uri="{1162E1C5-73C7-4A58-AE30-91384D911F3F}">
-                <p184:classification xmlns:p184="http://schemas.microsoft.com/office/powerpoint/2018/4/main" val="ftr"/>
-              </p:ext>
-            </p:extLst>
-          </p:nvPr>
-        </p:nvSpPr>
-        <p:spPr>
-          <a:xfrm>
-            <a:off x="190500" y="6545580"/>
-            <a:ext cx="830263" cy="121920"/>
-          </a:xfrm>
-          <a:prstGeom prst="rect">
-            <a:avLst/>
-          </a:prstGeom>
-        </p:spPr>
-        <p:txBody>
-          <a:bodyPr horzOverflow="overflow" lIns="0" tIns="0" rIns="0" bIns="0">
-            <a:spAutoFit/>
-          </a:bodyPr>
-          <a:lstStyle/>
-          <a:p>
-            <a:pPr algn="l"/>
-            <a:r>
-              <a:rPr lang="nb-NO" sz="800">
-                <a:solidFill>
-                  <a:srgbClr val="000000">
-                    <a:alpha val="50000"/>
-                  </a:srgbClr>
-                </a:solidFill>
-                <a:latin typeface="Times New Roman" panose="02020603050405020304" pitchFamily="18" charset="0"/>
-                <a:cs typeface="Times New Roman" panose="02020603050405020304" pitchFamily="18" charset="0"/>
-              </a:rPr>
-              <a:t>Sensitivity: Internal</a:t>
-            </a:r>
-          </a:p>
-        </p:txBody>
-      </p:sp>
     </p:spTree>
   </p:cSld>
   <p:clrMap bg1="lt1" tx1="dk1" bg2="lt2" tx2="dk2" accent1="accent1" accent2="accent2" accent3="accent3" accent4="accent4" accent5="accent5" accent6="accent6" hlink="hlink" folHlink="folHlink"/>
@@ -1113,7 +1391,7 @@
     <p:bg>
       <p:bgPr>
         <a:blipFill dpi="0" rotWithShape="1">
-          <a:blip r:embed="rId3">
+          <a:blip r:embed="rId1">
             <a:lum/>
           </a:blip>
           <a:srcRect/>
@@ -1152,7 +1430,7 @@
     <p:bg>
       <p:bgPr>
         <a:blipFill dpi="0" rotWithShape="1">
-          <a:blip r:embed="rId3">
+          <a:blip r:embed="rId1">
             <a:lum/>
           </a:blip>
           <a:srcRect/>
@@ -1191,7 +1469,7 @@
     <p:bg>
       <p:bgPr>
         <a:blipFill dpi="0" rotWithShape="1">
-          <a:blip r:embed="rId3">
+          <a:blip r:embed="rId1">
             <a:lum/>
           </a:blip>
           <a:srcRect/>
@@ -1230,7 +1508,7 @@
     <p:bg>
       <p:bgPr>
         <a:blipFill dpi="0" rotWithShape="1">
-          <a:blip r:embed="rId3">
+          <a:blip r:embed="rId1">
             <a:lum/>
           </a:blip>
           <a:srcRect/>
@@ -1269,7 +1547,7 @@
     <p:bg>
       <p:bgPr>
         <a:blipFill dpi="0" rotWithShape="1">
-          <a:blip r:embed="rId3">
+          <a:blip r:embed="rId1">
             <a:lum/>
           </a:blip>
           <a:srcRect/>
@@ -1308,7 +1586,46 @@
     <p:bg>
       <p:bgPr>
         <a:blipFill dpi="0" rotWithShape="1">
-          <a:blip r:embed="rId3">
+          <a:blip r:embed="rId1">
+            <a:lum/>
+          </a:blip>
+          <a:srcRect/>
+          <a:stretch>
+            <a:fillRect/>
+          </a:stretch>
+        </a:blipFill>
+        <a:effectLst/>
+      </p:bgPr>
+    </p:bg>
+    <p:spTree>
+      <p:nvGrpSpPr>
+        <p:cNvPr id="1" name=""/>
+        <p:cNvGrpSpPr/>
+        <p:nvPr/>
+      </p:nvGrpSpPr>
+      <p:grpSpPr>
+        <a:xfrm>
+          <a:off x="0" y="0"/>
+          <a:ext cx="0" cy="0"/>
+          <a:chOff x="0" y="0"/>
+          <a:chExt cx="0" cy="0"/>
+        </a:xfrm>
+      </p:grpSpPr>
+    </p:spTree>
+  </p:cSld>
+  <p:clrMapOvr>
+    <a:masterClrMapping/>
+  </p:clrMapOvr>
+</p:sld>
+</file>
+
+<file path=ppt/slides/slide7.xml><?xml version="1.0" encoding="utf-8"?>
+<p:sld xmlns:a="http://schemas.openxmlformats.org/drawingml/2006/main" xmlns:r="http://schemas.openxmlformats.org/officeDocument/2006/relationships" xmlns:p="http://schemas.openxmlformats.org/presentationml/2006/main">
+  <p:cSld name="Slide 7">
+    <p:bg>
+      <p:bgPr>
+        <a:blipFill dpi="0" rotWithShape="1">
+          <a:blip r:embed="rId1">
             <a:lum/>
           </a:blip>
           <a:srcRect/>
@@ -1634,325 +1951,4 @@
     </a:ext>
   </a:extLst>
 </a:theme>
-</file>
-
-<file path=ppt/theme/theme2.xml><?xml version="1.0" encoding="utf-8"?>
-<a:theme xmlns:a="http://schemas.openxmlformats.org/drawingml/2006/main" name="Office Theme">
-  <a:themeElements>
-    <a:clrScheme name="Office">
-      <a:dk1>
-        <a:sysClr val="windowText" lastClr="000000"/>
-      </a:dk1>
-      <a:lt1>
-        <a:sysClr val="window" lastClr="FFFFFF"/>
-      </a:lt1>
-      <a:dk2>
-        <a:srgbClr val="0E2841"/>
-      </a:dk2>
-      <a:lt2>
-        <a:srgbClr val="E8E8E8"/>
-      </a:lt2>
-      <a:accent1>
-        <a:srgbClr val="156082"/>
-      </a:accent1>
-      <a:accent2>
-        <a:srgbClr val="E97132"/>
-      </a:accent2>
-      <a:accent3>
-        <a:srgbClr val="196B24"/>
-      </a:accent3>
-      <a:accent4>
-        <a:srgbClr val="0F9ED5"/>
-      </a:accent4>
-      <a:accent5>
-        <a:srgbClr val="A02B93"/>
-      </a:accent5>
-      <a:accent6>
-        <a:srgbClr val="4EA72E"/>
-      </a:accent6>
-      <a:hlink>
-        <a:srgbClr val="467886"/>
-      </a:hlink>
-      <a:folHlink>
-        <a:srgbClr val="96607D"/>
-      </a:folHlink>
-    </a:clrScheme>
-    <a:fontScheme name="Office">
-      <a:majorFont>
-        <a:latin typeface="Aptos Display" panose="02110004020202020204"/>
-        <a:ea typeface=""/>
-        <a:cs typeface=""/>
-        <a:font script="Jpan" typeface="游ゴシック Light"/>
-        <a:font script="Hang" typeface="맑은 고딕"/>
-        <a:font script="Hans" typeface="等线 Light"/>
-        <a:font script="Hant" typeface="新細明體"/>
-        <a:font script="Arab" typeface="Times New Roman"/>
-        <a:font script="Hebr" typeface="Times New Roman"/>
-        <a:font script="Thai" typeface="Angsana New"/>
-        <a:font script="Ethi" typeface="Nyala"/>
-        <a:font script="Beng" typeface="Vrinda"/>
-        <a:font script="Gujr" typeface="Shruti"/>
-        <a:font script="Khmr" typeface="MoolBoran"/>
-        <a:font script="Knda" typeface="Tunga"/>
-        <a:font script="Guru" typeface="Raavi"/>
-        <a:font script="Cans" typeface="Euphemia"/>
-        <a:font script="Cher" typeface="Plantagenet Cherokee"/>
-        <a:font script="Yiii" typeface="Microsoft Yi Baiti"/>
-        <a:font script="Tibt" typeface="Microsoft Himalaya"/>
-        <a:font script="Thaa" typeface="MV Boli"/>
-        <a:font script="Deva" typeface="Mangal"/>
-        <a:font script="Telu" typeface="Gautami"/>
-        <a:font script="Taml" typeface="Latha"/>
-        <a:font script="Syrc" typeface="Estrangelo Edessa"/>
-        <a:font script="Orya" typeface="Kalinga"/>
-        <a:font script="Mlym" typeface="Kartika"/>
-        <a:font script="Laoo" typeface="DokChampa"/>
-        <a:font script="Sinh" typeface="Iskoola Pota"/>
-        <a:font script="Mong" typeface="Mongolian Baiti"/>
-        <a:font script="Viet" typeface="Times New Roman"/>
-        <a:font script="Uigh" typeface="Microsoft Uighur"/>
-        <a:font script="Geor" typeface="Sylfaen"/>
-        <a:font script="Armn" typeface="Arial"/>
-        <a:font script="Bugi" typeface="Leelawadee UI"/>
-        <a:font script="Bopo" typeface="Microsoft JhengHei"/>
-        <a:font script="Java" typeface="Javanese Text"/>
-        <a:font script="Lisu" typeface="Segoe UI"/>
-        <a:font script="Mymr" typeface="Myanmar Text"/>
-        <a:font script="Nkoo" typeface="Ebrima"/>
-        <a:font script="Olck" typeface="Nirmala UI"/>
-        <a:font script="Osma" typeface="Ebrima"/>
-        <a:font script="Phag" typeface="Phagspa"/>
-        <a:font script="Syrn" typeface="Estrangelo Edessa"/>
-        <a:font script="Syrj" typeface="Estrangelo Edessa"/>
-        <a:font script="Syre" typeface="Estrangelo Edessa"/>
-        <a:font script="Sora" typeface="Nirmala UI"/>
-        <a:font script="Tale" typeface="Microsoft Tai Le"/>
-        <a:font script="Talu" typeface="Microsoft New Tai Lue"/>
-        <a:font script="Tfng" typeface="Ebrima"/>
-      </a:majorFont>
-      <a:minorFont>
-        <a:latin typeface="Aptos" panose="02110004020202020204"/>
-        <a:ea typeface=""/>
-        <a:cs typeface=""/>
-        <a:font script="Jpan" typeface="游ゴシック"/>
-        <a:font script="Hang" typeface="맑은 고딕"/>
-        <a:font script="Hans" typeface="等线"/>
-        <a:font script="Hant" typeface="新細明體"/>
-        <a:font script="Arab" typeface="Arial"/>
-        <a:font script="Hebr" typeface="Arial"/>
-        <a:font script="Thai" typeface="Cordia New"/>
-        <a:font script="Ethi" typeface="Nyala"/>
-        <a:font script="Beng" typeface="Vrinda"/>
-        <a:font script="Gujr" typeface="Shruti"/>
-        <a:font script="Khmr" typeface="DaunPenh"/>
-        <a:font script="Knda" typeface="Tunga"/>
-        <a:font script="Guru" typeface="Raavi"/>
-        <a:font script="Cans" typeface="Euphemia"/>
-        <a:font script="Cher" typeface="Plantagenet Cherokee"/>
-        <a:font script="Yiii" typeface="Microsoft Yi Baiti"/>
-        <a:font script="Tibt" typeface="Microsoft Himalaya"/>
-        <a:font script="Thaa" typeface="MV Boli"/>
-        <a:font script="Deva" typeface="Mangal"/>
-        <a:font script="Telu" typeface="Gautami"/>
-        <a:font script="Taml" typeface="Latha"/>
-        <a:font script="Syrc" typeface="Estrangelo Edessa"/>
-        <a:font script="Orya" typeface="Kalinga"/>
-        <a:font script="Mlym" typeface="Kartika"/>
-        <a:font script="Laoo" typeface="DokChampa"/>
-        <a:font script="Sinh" typeface="Iskoola Pota"/>
-        <a:font script="Mong" typeface="Mongolian Baiti"/>
-        <a:font script="Viet" typeface="Arial"/>
-        <a:font script="Uigh" typeface="Microsoft Uighur"/>
-        <a:font script="Geor" typeface="Sylfaen"/>
-        <a:font script="Armn" typeface="Arial"/>
-        <a:font script="Bugi" typeface="Leelawadee UI"/>
-        <a:font script="Bopo" typeface="Microsoft JhengHei"/>
-        <a:font script="Java" typeface="Javanese Text"/>
-        <a:font script="Lisu" typeface="Segoe UI"/>
-        <a:font script="Mymr" typeface="Myanmar Text"/>
-        <a:font script="Nkoo" typeface="Ebrima"/>
-        <a:font script="Olck" typeface="Nirmala UI"/>
-        <a:font script="Osma" typeface="Ebrima"/>
-        <a:font script="Phag" typeface="Phagspa"/>
-        <a:font script="Syrn" typeface="Estrangelo Edessa"/>
-        <a:font script="Syrj" typeface="Estrangelo Edessa"/>
-        <a:font script="Syre" typeface="Estrangelo Edessa"/>
-        <a:font script="Sora" typeface="Nirmala UI"/>
-        <a:font script="Tale" typeface="Microsoft Tai Le"/>
-        <a:font script="Talu" typeface="Microsoft New Tai Lue"/>
-        <a:font script="Tfng" typeface="Ebrima"/>
-      </a:minorFont>
-    </a:fontScheme>
-    <a:fmtScheme name="Office">
-      <a:fillStyleLst>
-        <a:solidFill>
-          <a:schemeClr val="phClr"/>
-        </a:solidFill>
-        <a:gradFill rotWithShape="1">
-          <a:gsLst>
-            <a:gs pos="0">
-              <a:schemeClr val="phClr">
-                <a:lumMod val="110000"/>
-                <a:satMod val="105000"/>
-                <a:tint val="67000"/>
-              </a:schemeClr>
-            </a:gs>
-            <a:gs pos="50000">
-              <a:schemeClr val="phClr">
-                <a:lumMod val="105000"/>
-                <a:satMod val="103000"/>
-                <a:tint val="73000"/>
-              </a:schemeClr>
-            </a:gs>
-            <a:gs pos="100000">
-              <a:schemeClr val="phClr">
-                <a:lumMod val="105000"/>
-                <a:satMod val="109000"/>
-                <a:tint val="81000"/>
-              </a:schemeClr>
-            </a:gs>
-          </a:gsLst>
-          <a:lin ang="5400000" scaled="0"/>
-        </a:gradFill>
-        <a:gradFill rotWithShape="1">
-          <a:gsLst>
-            <a:gs pos="0">
-              <a:schemeClr val="phClr">
-                <a:satMod val="103000"/>
-                <a:lumMod val="102000"/>
-                <a:tint val="94000"/>
-              </a:schemeClr>
-            </a:gs>
-            <a:gs pos="50000">
-              <a:schemeClr val="phClr">
-                <a:satMod val="110000"/>
-                <a:lumMod val="100000"/>
-                <a:shade val="100000"/>
-              </a:schemeClr>
-            </a:gs>
-            <a:gs pos="100000">
-              <a:schemeClr val="phClr">
-                <a:lumMod val="99000"/>
-                <a:satMod val="120000"/>
-                <a:shade val="78000"/>
-              </a:schemeClr>
-            </a:gs>
-          </a:gsLst>
-          <a:lin ang="5400000" scaled="0"/>
-        </a:gradFill>
-      </a:fillStyleLst>
-      <a:lnStyleLst>
-        <a:ln w="12700" cap="flat" cmpd="sng" algn="ctr">
-          <a:solidFill>
-            <a:schemeClr val="phClr"/>
-          </a:solidFill>
-          <a:prstDash val="solid"/>
-          <a:miter lim="800000"/>
-        </a:ln>
-        <a:ln w="19050" cap="flat" cmpd="sng" algn="ctr">
-          <a:solidFill>
-            <a:schemeClr val="phClr"/>
-          </a:solidFill>
-          <a:prstDash val="solid"/>
-          <a:miter lim="800000"/>
-        </a:ln>
-        <a:ln w="25400" cap="flat" cmpd="sng" algn="ctr">
-          <a:solidFill>
-            <a:schemeClr val="phClr"/>
-          </a:solidFill>
-          <a:prstDash val="solid"/>
-          <a:miter lim="800000"/>
-        </a:ln>
-      </a:lnStyleLst>
-      <a:effectStyleLst>
-        <a:effectStyle>
-          <a:effectLst/>
-        </a:effectStyle>
-        <a:effectStyle>
-          <a:effectLst/>
-        </a:effectStyle>
-        <a:effectStyle>
-          <a:effectLst>
-            <a:outerShdw blurRad="57150" dist="19050" dir="5400000" algn="ctr" rotWithShape="0">
-              <a:srgbClr val="000000">
-                <a:alpha val="63000"/>
-              </a:srgbClr>
-            </a:outerShdw>
-          </a:effectLst>
-        </a:effectStyle>
-      </a:effectStyleLst>
-      <a:bgFillStyleLst>
-        <a:solidFill>
-          <a:schemeClr val="phClr"/>
-        </a:solidFill>
-        <a:solidFill>
-          <a:schemeClr val="phClr">
-            <a:tint val="95000"/>
-            <a:satMod val="170000"/>
-          </a:schemeClr>
-        </a:solidFill>
-        <a:gradFill rotWithShape="1">
-          <a:gsLst>
-            <a:gs pos="0">
-              <a:schemeClr val="phClr">
-                <a:tint val="93000"/>
-                <a:satMod val="150000"/>
-                <a:shade val="98000"/>
-                <a:lumMod val="102000"/>
-              </a:schemeClr>
-            </a:gs>
-            <a:gs pos="50000">
-              <a:schemeClr val="phClr">
-                <a:tint val="98000"/>
-                <a:satMod val="130000"/>
-                <a:shade val="90000"/>
-                <a:lumMod val="103000"/>
-              </a:schemeClr>
-            </a:gs>
-            <a:gs pos="100000">
-              <a:schemeClr val="phClr">
-                <a:shade val="63000"/>
-                <a:satMod val="120000"/>
-              </a:schemeClr>
-            </a:gs>
-          </a:gsLst>
-          <a:lin ang="5400000" scaled="0"/>
-        </a:gradFill>
-      </a:bgFillStyleLst>
-    </a:fmtScheme>
-  </a:themeElements>
-  <a:objectDefaults>
-    <a:lnDef>
-      <a:spPr/>
-      <a:bodyPr/>
-      <a:lstStyle/>
-      <a:style>
-        <a:lnRef idx="2">
-          <a:schemeClr val="accent1"/>
-        </a:lnRef>
-        <a:fillRef idx="0">
-          <a:schemeClr val="accent1"/>
-        </a:fillRef>
-        <a:effectRef idx="1">
-          <a:schemeClr val="accent1"/>
-        </a:effectRef>
-        <a:fontRef idx="minor">
-          <a:schemeClr val="tx1"/>
-        </a:fontRef>
-      </a:style>
-    </a:lnDef>
-  </a:objectDefaults>
-  <a:extraClrSchemeLst/>
-  <a:extLst>
-    <a:ext uri="{05A4C25C-085E-4340-85A3-A5531E510DB2}">
-      <thm15:themeFamily xmlns:thm15="http://schemas.microsoft.com/office/thememl/2012/main" name="Office Theme" id="{2E142A2C-CD16-42D6-873A-C26D2A0506FA}" vid="{1BDDFF52-6CD6-40A5-AB3C-68EB2F1E4D0A}"/>
-    </a:ext>
-  </a:extLst>
-</a:theme>
-</file>
-
-<file path=docMetadata/LabelInfo.xml><?xml version="1.0" encoding="utf-8"?>
-<clbl:labelList xmlns:clbl="http://schemas.microsoft.com/office/2020/mipLabelMetadata">
-  <clbl:label id="{18450391-6d50-49e0-a466-bfda2ff2a5e1}" enabled="1" method="Privileged" siteId="{65f51067-7d65-4aa9-b996-4cc43a0d7111}" contentBits="2" removed="0"/>
-</clbl:labelList>
 </file>
</xml_diff>